<commit_message>
Trim poster assets to source files only
</commit_message>
<xml_diff>
--- a/poster/poster.pptx
+++ b/poster/poster.pptx
@@ -156,7 +156,7 @@
             <a:srgbClr val="A4A3A4"/>
           </p15:clr>
         </p15:guide>
-        <p15:guide id="3" pos="-955" userDrawn="1">
+        <p15:guide id="3" pos="-949" userDrawn="1">
           <p15:clr>
             <a:srgbClr val="A4A3A4"/>
           </p15:clr>
@@ -520,7 +520,7 @@
         </a:solidFill>
         <a:latin typeface="Arial" panose="020B0704020202020204" pitchFamily="34" charset="0"/>
         <a:ea typeface="MS PGothic" panose="020B0600070205080204" pitchFamily="34" charset="-128"/>
-        <a:cs typeface="MS PGothic" charset="-128"/>
+        <a:cs typeface="MS PGothic" panose="020B0600070205080204" pitchFamily="34" charset="-128"/>
       </a:defRPr>
     </a:lvl1pPr>
     <a:lvl2pPr marL="457200" algn="l" rtl="0" eaLnBrk="0" fontAlgn="base" hangingPunct="0">
@@ -7016,7 +7016,7 @@
           </a:solidFill>
           <a:latin typeface="+mj-lt"/>
           <a:ea typeface="MS PGothic" panose="020B0600070205080204" pitchFamily="34" charset="-128"/>
-          <a:cs typeface="MS PGothic" charset="-128"/>
+          <a:cs typeface="MS PGothic" panose="020B0600070205080204" pitchFamily="34" charset="-128"/>
         </a:defRPr>
       </a:lvl1pPr>
       <a:lvl2pPr algn="ctr" defTabSz="749300" rtl="0" eaLnBrk="0" fontAlgn="base" hangingPunct="0">
@@ -7032,7 +7032,7 @@
           </a:solidFill>
           <a:latin typeface="Arial Black" panose="020B0A04020102020204" charset="0"/>
           <a:ea typeface="MS PGothic" panose="020B0600070205080204" pitchFamily="34" charset="-128"/>
-          <a:cs typeface="MS PGothic" charset="-128"/>
+          <a:cs typeface="MS PGothic" panose="020B0600070205080204" pitchFamily="34" charset="-128"/>
         </a:defRPr>
       </a:lvl2pPr>
       <a:lvl3pPr algn="ctr" defTabSz="749300" rtl="0" eaLnBrk="0" fontAlgn="base" hangingPunct="0">
@@ -7048,7 +7048,7 @@
           </a:solidFill>
           <a:latin typeface="Arial Black" panose="020B0A04020102020204" charset="0"/>
           <a:ea typeface="MS PGothic" panose="020B0600070205080204" pitchFamily="34" charset="-128"/>
-          <a:cs typeface="MS PGothic" charset="-128"/>
+          <a:cs typeface="MS PGothic" panose="020B0600070205080204" pitchFamily="34" charset="-128"/>
         </a:defRPr>
       </a:lvl3pPr>
       <a:lvl4pPr algn="ctr" defTabSz="749300" rtl="0" eaLnBrk="0" fontAlgn="base" hangingPunct="0">
@@ -7064,7 +7064,7 @@
           </a:solidFill>
           <a:latin typeface="Arial Black" panose="020B0A04020102020204" charset="0"/>
           <a:ea typeface="MS PGothic" panose="020B0600070205080204" pitchFamily="34" charset="-128"/>
-          <a:cs typeface="MS PGothic" charset="-128"/>
+          <a:cs typeface="MS PGothic" panose="020B0600070205080204" pitchFamily="34" charset="-128"/>
         </a:defRPr>
       </a:lvl4pPr>
       <a:lvl5pPr algn="ctr" defTabSz="749300" rtl="0" eaLnBrk="0" fontAlgn="base" hangingPunct="0">
@@ -7080,7 +7080,7 @@
           </a:solidFill>
           <a:latin typeface="Arial Black" panose="020B0A04020102020204" charset="0"/>
           <a:ea typeface="MS PGothic" panose="020B0600070205080204" pitchFamily="34" charset="-128"/>
-          <a:cs typeface="MS PGothic" charset="-128"/>
+          <a:cs typeface="MS PGothic" panose="020B0600070205080204" pitchFamily="34" charset="-128"/>
         </a:defRPr>
       </a:lvl5pPr>
       <a:lvl6pPr marL="457200" algn="ctr" defTabSz="749300" rtl="0" fontAlgn="base">
@@ -7155,7 +7155,7 @@
           </a:solidFill>
           <a:latin typeface="+mn-lt"/>
           <a:ea typeface="MS PGothic" panose="020B0600070205080204" pitchFamily="34" charset="-128"/>
-          <a:cs typeface="MS PGothic" charset="-128"/>
+          <a:cs typeface="MS PGothic" panose="020B0600070205080204" pitchFamily="34" charset="-128"/>
         </a:defRPr>
       </a:lvl1pPr>
       <a:lvl2pPr marL="439420" indent="-168275" algn="l" defTabSz="542925" rtl="0" eaLnBrk="0" fontAlgn="base" hangingPunct="0">
@@ -7239,7 +7239,7 @@
             <a:schemeClr val="tx1"/>
           </a:solidFill>
           <a:latin typeface="+mn-lt"/>
-          <a:ea typeface="MS PGothic" charset="-128"/>
+          <a:ea typeface="MS PGothic" panose="020B0600070205080204" pitchFamily="34" charset="-128"/>
         </a:defRPr>
       </a:lvl6pPr>
       <a:lvl7pPr marL="1886585" indent="-135890" algn="l" defTabSz="542925" rtl="0" fontAlgn="base">
@@ -7255,7 +7255,7 @@
             <a:schemeClr val="tx1"/>
           </a:solidFill>
           <a:latin typeface="+mn-lt"/>
-          <a:ea typeface="MS PGothic" charset="-128"/>
+          <a:ea typeface="MS PGothic" panose="020B0600070205080204" pitchFamily="34" charset="-128"/>
         </a:defRPr>
       </a:lvl7pPr>
       <a:lvl8pPr marL="2217420" indent="-135890" algn="l" defTabSz="542925" rtl="0" fontAlgn="base">
@@ -7271,7 +7271,7 @@
             <a:schemeClr val="tx1"/>
           </a:solidFill>
           <a:latin typeface="+mn-lt"/>
-          <a:ea typeface="MS PGothic" charset="-128"/>
+          <a:ea typeface="MS PGothic" panose="020B0600070205080204" pitchFamily="34" charset="-128"/>
         </a:defRPr>
       </a:lvl8pPr>
       <a:lvl9pPr marL="2548890" indent="-135890" algn="l" defTabSz="542925" rtl="0" fontAlgn="base">
@@ -7287,7 +7287,7 @@
             <a:schemeClr val="tx1"/>
           </a:solidFill>
           <a:latin typeface="+mn-lt"/>
-          <a:ea typeface="MS PGothic" charset="-128"/>
+          <a:ea typeface="MS PGothic" panose="020B0600070205080204" pitchFamily="34" charset="-128"/>
         </a:defRPr>
       </a:lvl9pPr>
     </p:bodyStyle>
@@ -7581,7 +7581,6 @@
           <a:bodyPr anchor="t"/>
           <a:lstStyle/>
           <a:p>
-            <a:pPr/>
             <a:r>
               <a:rPr lang="en-US" altLang="en-US" sz="2610" dirty="0">
                 <a:solidFill>
@@ -7597,7 +7596,6 @@
             </a:endParaRPr>
           </a:p>
           <a:p>
-            <a:pPr/>
             <a:r>
               <a:rPr lang="en-US" altLang="en-US" sz="2610" dirty="0">
                 <a:solidFill>
@@ -7613,7 +7611,6 @@
             </a:endParaRPr>
           </a:p>
           <a:p>
-            <a:pPr/>
             <a:endParaRPr lang="en-US" altLang="en-US" sz="2610" dirty="0">
               <a:solidFill>
                 <a:schemeClr val="tx1"/>
@@ -7621,7 +7618,6 @@
             </a:endParaRPr>
           </a:p>
           <a:p>
-            <a:pPr/>
             <a:r>
               <a:rPr lang="en-US" altLang="en-US" sz="2610" dirty="0">
                 <a:solidFill>
@@ -7637,7 +7633,6 @@
             </a:endParaRPr>
           </a:p>
           <a:p>
-            <a:pPr/>
             <a:r>
               <a:rPr lang="en-US" altLang="en-US" sz="2610" dirty="0">
                 <a:solidFill>
@@ -7653,7 +7648,6 @@
             </a:endParaRPr>
           </a:p>
           <a:p>
-            <a:pPr/>
             <a:r>
               <a:rPr lang="en-US" altLang="en-US" sz="2610" dirty="0">
                 <a:solidFill>
@@ -7669,7 +7663,6 @@
             </a:endParaRPr>
           </a:p>
           <a:p>
-            <a:pPr/>
             <a:endParaRPr lang="en-US" altLang="en-US" sz="2610" dirty="0">
               <a:solidFill>
                 <a:schemeClr val="tx1"/>
@@ -7692,10 +7685,11 @@
           <a:prstGeom prst="rect">
             <a:avLst/>
           </a:prstGeom>
-          <a:ln>
+          <a:ln w="25400" cap="flat" cmpd="sng">
             <a:solidFill>
               <a:srgbClr val="FFC000"/>
             </a:solidFill>
+            <a:prstDash val="solid"/>
             <a:headEnd type="none" w="med" len="med"/>
             <a:tailEnd type="none" w="med" len="med"/>
           </a:ln>
@@ -8218,10 +8212,11 @@
             <a:avLst/>
           </a:prstGeom>
           <a:noFill/>
-          <a:ln>
+          <a:ln w="25400" cap="flat" cmpd="sng">
             <a:solidFill>
               <a:srgbClr val="FFC000"/>
             </a:solidFill>
+            <a:prstDash val="solid"/>
             <a:headEnd type="none" w="med" len="med"/>
             <a:tailEnd type="none" w="med" len="med"/>
           </a:ln>
@@ -8802,7 +8797,7 @@
           <a:solidFill>
             <a:schemeClr val="bg1"/>
           </a:solidFill>
-          <a:ln w="9525" cap="flat" cmpd="sng" algn="ctr">
+          <a:ln w="25400" cap="flat" cmpd="sng" algn="ctr">
             <a:solidFill>
               <a:srgbClr val="FFC000"/>
             </a:solidFill>

</xml_diff>